<commit_message>
material added for second day
</commit_message>
<xml_diff>
--- a/21-05-2026/test cases.pptx
+++ b/21-05-2026/test cases.pptx
@@ -9776,7 +9776,7 @@
               <a:buNone/>
             </a:pPr>
             <a:r>
-              <a:rPr lang="en-US" b="1">
+              <a:rPr lang="en-US" sz="2400" b="1">
                 <a:solidFill>
                   <a:srgbClr val="002060"/>
                 </a:solidFill>
@@ -9784,14 +9784,14 @@
               <a:t>TC1 - &gt;</a:t>
             </a:r>
             <a:r>
-              <a:rPr lang="en-US">
+              <a:rPr lang="en-US" sz="2400">
                 <a:solidFill>
                   <a:srgbClr val="002060"/>
                 </a:solidFill>
               </a:rPr>
               <a:t>[3,1], [7,4]</a:t>
             </a:r>
-            <a:endParaRPr lang="en-US">
+            <a:endParaRPr lang="en-US" sz="2400">
               <a:solidFill>
                 <a:srgbClr val="002060"/>
               </a:solidFill>
@@ -9805,7 +9805,7 @@
               <a:buNone/>
             </a:pPr>
             <a:r>
-              <a:rPr lang="en-US" b="1">
+              <a:rPr lang="en-US" sz="2400" b="1">
                 <a:solidFill>
                   <a:srgbClr val="002060"/>
                 </a:solidFill>
@@ -9813,14 +9813,14 @@
               <a:t>OP -&gt; </a:t>
             </a:r>
             <a:r>
-              <a:rPr lang="en-US">
+              <a:rPr lang="en-US" sz="2400">
                 <a:solidFill>
                   <a:srgbClr val="002060"/>
                 </a:solidFill>
               </a:rPr>
               <a:t>[1,3,4,7]</a:t>
             </a:r>
-            <a:endParaRPr lang="en-US">
+            <a:endParaRPr lang="en-US" sz="2400">
               <a:solidFill>
                 <a:srgbClr val="002060"/>
               </a:solidFill>
@@ -9834,7 +9834,7 @@
               <a:buNone/>
             </a:pPr>
             <a:r>
-              <a:rPr lang="en-US" b="1">
+              <a:rPr lang="en-US" sz="2400" b="1">
                 <a:solidFill>
                   <a:srgbClr val="002060"/>
                 </a:solidFill>
@@ -9843,7 +9843,7 @@
               <a:t>TC2 -&gt; </a:t>
             </a:r>
             <a:r>
-              <a:rPr lang="en-US">
+              <a:rPr lang="en-US" sz="2400">
                 <a:solidFill>
                   <a:srgbClr val="002060"/>
                 </a:solidFill>
@@ -9851,7 +9851,7 @@
               </a:rPr>
               <a:t>[4,1], [7,4]</a:t>
             </a:r>
-            <a:endParaRPr lang="en-US">
+            <a:endParaRPr lang="en-US" sz="2400">
               <a:solidFill>
                 <a:srgbClr val="002060"/>
               </a:solidFill>
@@ -9866,7 +9866,7 @@
               <a:buNone/>
             </a:pPr>
             <a:r>
-              <a:rPr lang="en-US" b="1">
+              <a:rPr lang="en-US" sz="2400" b="1">
                 <a:solidFill>
                   <a:srgbClr val="002060"/>
                 </a:solidFill>
@@ -9875,7 +9875,7 @@
               <a:t>OP -&gt; </a:t>
             </a:r>
             <a:r>
-              <a:rPr lang="en-US">
+              <a:rPr lang="en-US" sz="2400">
                 <a:solidFill>
                   <a:srgbClr val="002060"/>
                 </a:solidFill>
@@ -9883,7 +9883,7 @@
               </a:rPr>
               <a:t>[1, 4, 7]</a:t>
             </a:r>
-            <a:endParaRPr lang="en-US">
+            <a:endParaRPr lang="en-US" sz="2400">
               <a:solidFill>
                 <a:srgbClr val="002060"/>
               </a:solidFill>
@@ -9898,7 +9898,7 @@
               <a:buNone/>
             </a:pPr>
             <a:r>
-              <a:rPr lang="en-US" b="1">
+              <a:rPr lang="en-US" sz="2400" b="1">
                 <a:solidFill>
                   <a:srgbClr val="002060"/>
                 </a:solidFill>
@@ -9907,7 +9907,7 @@
               <a:t>TC3 -&gt; </a:t>
             </a:r>
             <a:r>
-              <a:rPr lang="en-US">
+              <a:rPr lang="en-US" sz="2400">
                 <a:solidFill>
                   <a:srgbClr val="002060"/>
                 </a:solidFill>
@@ -9915,7 +9915,7 @@
               </a:rPr>
               <a:t>[4,2], [2,4]</a:t>
             </a:r>
-            <a:endParaRPr lang="en-US">
+            <a:endParaRPr lang="en-US" sz="2400">
               <a:solidFill>
                 <a:srgbClr val="002060"/>
               </a:solidFill>
@@ -9930,7 +9930,7 @@
               <a:buNone/>
             </a:pPr>
             <a:r>
-              <a:rPr lang="en-US" b="1">
+              <a:rPr lang="en-US" sz="2400" b="1">
                 <a:solidFill>
                   <a:srgbClr val="002060"/>
                 </a:solidFill>
@@ -9939,7 +9939,7 @@
               <a:t>OP -&gt; </a:t>
             </a:r>
             <a:r>
-              <a:rPr lang="en-US">
+              <a:rPr lang="en-US" sz="2400">
                 <a:solidFill>
                   <a:srgbClr val="002060"/>
                 </a:solidFill>
@@ -9947,7 +9947,7 @@
               </a:rPr>
               <a:t>[2,4]</a:t>
             </a:r>
-            <a:endParaRPr lang="en-US">
+            <a:endParaRPr lang="en-US" sz="2400">
               <a:solidFill>
                 <a:srgbClr val="002060"/>
               </a:solidFill>
@@ -9962,7 +9962,7 @@
               <a:buNone/>
             </a:pPr>
             <a:r>
-              <a:rPr lang="en-US" b="1">
+              <a:rPr lang="en-US" sz="2400" b="1">
                 <a:solidFill>
                   <a:srgbClr val="002060"/>
                 </a:solidFill>
@@ -9971,7 +9971,7 @@
               <a:t>TC4 -&gt; </a:t>
             </a:r>
             <a:r>
-              <a:rPr lang="en-US">
+              <a:rPr lang="en-US" sz="2400">
                 <a:solidFill>
                   <a:srgbClr val="002060"/>
                 </a:solidFill>
@@ -9979,7 +9979,7 @@
               </a:rPr>
               <a:t>[4,2,1], [7,4,5]</a:t>
             </a:r>
-            <a:endParaRPr lang="en-US">
+            <a:endParaRPr lang="en-US" sz="2400">
               <a:solidFill>
                 <a:srgbClr val="002060"/>
               </a:solidFill>
@@ -9994,7 +9994,7 @@
               <a:buNone/>
             </a:pPr>
             <a:r>
-              <a:rPr lang="en-US" b="1">
+              <a:rPr lang="en-US" sz="2400" b="1">
                 <a:solidFill>
                   <a:srgbClr val="002060"/>
                 </a:solidFill>
@@ -10003,7 +10003,7 @@
               <a:t>OP -&gt; </a:t>
             </a:r>
             <a:r>
-              <a:rPr lang="en-US">
+              <a:rPr lang="en-US" sz="2400">
                 <a:solidFill>
                   <a:srgbClr val="002060"/>
                 </a:solidFill>
@@ -10011,7 +10011,7 @@
               </a:rPr>
               <a:t>[1, 2, 4, 5, 7]</a:t>
             </a:r>
-            <a:endParaRPr lang="en-US">
+            <a:endParaRPr lang="en-US" sz="2400">
               <a:solidFill>
                 <a:srgbClr val="002060"/>
               </a:solidFill>
@@ -10026,7 +10026,7 @@
               <a:buNone/>
             </a:pPr>
             <a:r>
-              <a:rPr lang="en-US" b="1">
+              <a:rPr lang="en-US" sz="2400" b="1">
                 <a:solidFill>
                   <a:srgbClr val="002060"/>
                 </a:solidFill>
@@ -10035,7 +10035,7 @@
               <a:t>TC5-&gt;</a:t>
             </a:r>
             <a:r>
-              <a:rPr lang="en-US">
+              <a:rPr lang="en-US" sz="2400">
                 <a:solidFill>
                   <a:srgbClr val="002060"/>
                 </a:solidFill>
@@ -10043,7 +10043,7 @@
               </a:rPr>
               <a:t>[3,1], [7,2]</a:t>
             </a:r>
-            <a:endParaRPr lang="en-US">
+            <a:endParaRPr lang="en-US" sz="2400">
               <a:solidFill>
                 <a:srgbClr val="002060"/>
               </a:solidFill>
@@ -10058,7 +10058,7 @@
               <a:buNone/>
             </a:pPr>
             <a:r>
-              <a:rPr lang="en-US" b="1">
+              <a:rPr lang="en-US" sz="2400" b="1">
                 <a:solidFill>
                   <a:srgbClr val="002060"/>
                 </a:solidFill>
@@ -10067,7 +10067,7 @@
               <a:t>OP -&gt; </a:t>
             </a:r>
             <a:r>
-              <a:rPr lang="en-US">
+              <a:rPr lang="en-US" sz="2400">
                 <a:solidFill>
                   <a:srgbClr val="002060"/>
                 </a:solidFill>
@@ -10075,7 +10075,7 @@
               </a:rPr>
               <a:t>[1,2,3,7]</a:t>
             </a:r>
-            <a:endParaRPr lang="en-US">
+            <a:endParaRPr lang="en-US" sz="2400">
               <a:solidFill>
                 <a:srgbClr val="002060"/>
               </a:solidFill>
@@ -10087,7 +10087,7 @@
                 <a:spcPct val="140000"/>
               </a:lnSpc>
             </a:pPr>
-            <a:endParaRPr lang="en-US">
+            <a:endParaRPr lang="en-US" sz="2400">
               <a:solidFill>
                 <a:srgbClr val="002060"/>
               </a:solidFill>
@@ -10370,7 +10370,7 @@
               <a:buNone/>
             </a:pPr>
             <a:r>
-              <a:rPr lang="en-US" b="1">
+              <a:rPr lang="en-US" sz="2400" b="1">
                 <a:solidFill>
                   <a:srgbClr val="002060"/>
                 </a:solidFill>
@@ -10379,7 +10379,7 @@
               <a:t>TC1 - &gt;</a:t>
             </a:r>
             <a:r>
-              <a:rPr lang="en-US">
+              <a:rPr lang="en-US" sz="2400">
                 <a:solidFill>
                   <a:srgbClr val="002060"/>
                 </a:solidFill>
@@ -10387,7 +10387,7 @@
               </a:rPr>
               <a:t>[3,1], [7,4]</a:t>
             </a:r>
-            <a:endParaRPr lang="en-US">
+            <a:endParaRPr lang="en-US" sz="2400">
               <a:solidFill>
                 <a:srgbClr val="002060"/>
               </a:solidFill>
@@ -10401,7 +10401,7 @@
               <a:buNone/>
             </a:pPr>
             <a:r>
-              <a:rPr lang="en-US" b="1">
+              <a:rPr lang="en-US" sz="2400" b="1">
                 <a:solidFill>
                   <a:srgbClr val="002060"/>
                 </a:solidFill>
@@ -10410,7 +10410,7 @@
               <a:t>OP -&gt; </a:t>
             </a:r>
             <a:r>
-              <a:rPr lang="en-US">
+              <a:rPr lang="en-US" sz="2400">
                 <a:solidFill>
                   <a:srgbClr val="002060"/>
                 </a:solidFill>
@@ -10418,7 +10418,7 @@
               </a:rPr>
               <a:t>[1,3,4,7]</a:t>
             </a:r>
-            <a:endParaRPr lang="en-US">
+            <a:endParaRPr lang="en-US" sz="2400">
               <a:solidFill>
                 <a:srgbClr val="002060"/>
               </a:solidFill>
@@ -10432,7 +10432,7 @@
               <a:buNone/>
             </a:pPr>
             <a:r>
-              <a:rPr lang="en-US" b="1">
+              <a:rPr lang="en-US" sz="2400" b="1">
                 <a:solidFill>
                   <a:srgbClr val="002060"/>
                 </a:solidFill>
@@ -10441,7 +10441,7 @@
               <a:t>TC2 -&gt; </a:t>
             </a:r>
             <a:r>
-              <a:rPr lang="en-US">
+              <a:rPr lang="en-US" sz="2400">
                 <a:solidFill>
                   <a:srgbClr val="002060"/>
                 </a:solidFill>
@@ -10449,7 +10449,7 @@
               </a:rPr>
               <a:t>[4,1], [7,4]</a:t>
             </a:r>
-            <a:endParaRPr lang="en-US">
+            <a:endParaRPr lang="en-US" sz="2400">
               <a:solidFill>
                 <a:srgbClr val="002060"/>
               </a:solidFill>
@@ -10464,7 +10464,7 @@
               <a:buNone/>
             </a:pPr>
             <a:r>
-              <a:rPr lang="en-US" b="1">
+              <a:rPr lang="en-US" sz="2400" b="1">
                 <a:solidFill>
                   <a:srgbClr val="002060"/>
                 </a:solidFill>
@@ -10473,7 +10473,7 @@
               <a:t>OP -&gt; </a:t>
             </a:r>
             <a:r>
-              <a:rPr lang="en-US">
+              <a:rPr lang="en-US" sz="2400">
                 <a:solidFill>
                   <a:srgbClr val="002060"/>
                 </a:solidFill>
@@ -10481,7 +10481,7 @@
               </a:rPr>
               <a:t>[1, 4, 7]</a:t>
             </a:r>
-            <a:endParaRPr lang="en-US">
+            <a:endParaRPr lang="en-US" sz="2400">
               <a:solidFill>
                 <a:srgbClr val="002060"/>
               </a:solidFill>
@@ -10496,7 +10496,7 @@
               <a:buNone/>
             </a:pPr>
             <a:r>
-              <a:rPr lang="en-US" b="1">
+              <a:rPr lang="en-US" sz="2400" b="1">
                 <a:solidFill>
                   <a:srgbClr val="002060"/>
                 </a:solidFill>
@@ -10505,7 +10505,7 @@
               <a:t>TC3 -&gt; </a:t>
             </a:r>
             <a:r>
-              <a:rPr lang="en-US">
+              <a:rPr lang="en-US" sz="2400">
                 <a:solidFill>
                   <a:srgbClr val="002060"/>
                 </a:solidFill>
@@ -10513,7 +10513,7 @@
               </a:rPr>
               <a:t>[4,2], [2,4]</a:t>
             </a:r>
-            <a:endParaRPr lang="en-US">
+            <a:endParaRPr lang="en-US" sz="2400">
               <a:solidFill>
                 <a:srgbClr val="002060"/>
               </a:solidFill>
@@ -10528,7 +10528,7 @@
               <a:buNone/>
             </a:pPr>
             <a:r>
-              <a:rPr lang="en-US" b="1">
+              <a:rPr lang="en-US" sz="2400" b="1">
                 <a:solidFill>
                   <a:srgbClr val="002060"/>
                 </a:solidFill>
@@ -10537,7 +10537,7 @@
               <a:t>OP -&gt; </a:t>
             </a:r>
             <a:r>
-              <a:rPr lang="en-US">
+              <a:rPr lang="en-US" sz="2400">
                 <a:solidFill>
                   <a:srgbClr val="002060"/>
                 </a:solidFill>
@@ -10545,7 +10545,7 @@
               </a:rPr>
               <a:t>[2,4]</a:t>
             </a:r>
-            <a:endParaRPr lang="en-US">
+            <a:endParaRPr lang="en-US" sz="2400">
               <a:solidFill>
                 <a:srgbClr val="002060"/>
               </a:solidFill>
@@ -10560,7 +10560,7 @@
               <a:buNone/>
             </a:pPr>
             <a:r>
-              <a:rPr lang="en-US" b="1">
+              <a:rPr lang="en-US" sz="2400" b="1">
                 <a:solidFill>
                   <a:srgbClr val="002060"/>
                 </a:solidFill>
@@ -10569,7 +10569,7 @@
               <a:t>TC4 -&gt; </a:t>
             </a:r>
             <a:r>
-              <a:rPr lang="en-US">
+              <a:rPr lang="en-US" sz="2400">
                 <a:solidFill>
                   <a:srgbClr val="002060"/>
                 </a:solidFill>
@@ -10577,7 +10577,7 @@
               </a:rPr>
               <a:t>[4,2,1], [7,4,5]</a:t>
             </a:r>
-            <a:endParaRPr lang="en-US">
+            <a:endParaRPr lang="en-US" sz="2400">
               <a:solidFill>
                 <a:srgbClr val="002060"/>
               </a:solidFill>
@@ -10592,7 +10592,7 @@
               <a:buNone/>
             </a:pPr>
             <a:r>
-              <a:rPr lang="en-US" b="1">
+              <a:rPr lang="en-US" sz="2400" b="1">
                 <a:solidFill>
                   <a:srgbClr val="002060"/>
                 </a:solidFill>
@@ -10601,7 +10601,7 @@
               <a:t>OP -&gt; </a:t>
             </a:r>
             <a:r>
-              <a:rPr lang="en-US">
+              <a:rPr lang="en-US" sz="2400">
                 <a:solidFill>
                   <a:srgbClr val="002060"/>
                 </a:solidFill>
@@ -10609,7 +10609,7 @@
               </a:rPr>
               <a:t>[1, 2, 4, 5, 7]</a:t>
             </a:r>
-            <a:endParaRPr lang="en-US">
+            <a:endParaRPr lang="en-US" sz="2400">
               <a:solidFill>
                 <a:srgbClr val="002060"/>
               </a:solidFill>
@@ -10624,7 +10624,7 @@
               <a:buNone/>
             </a:pPr>
             <a:r>
-              <a:rPr lang="en-US" b="1">
+              <a:rPr lang="en-US" sz="2400" b="1">
                 <a:solidFill>
                   <a:srgbClr val="002060"/>
                 </a:solidFill>
@@ -10633,7 +10633,7 @@
               <a:t>TC5-&gt;</a:t>
             </a:r>
             <a:r>
-              <a:rPr lang="en-US">
+              <a:rPr lang="en-US" sz="2400">
                 <a:solidFill>
                   <a:srgbClr val="002060"/>
                 </a:solidFill>
@@ -10641,7 +10641,7 @@
               </a:rPr>
               <a:t>[3,1], [7,2]</a:t>
             </a:r>
-            <a:endParaRPr lang="en-US">
+            <a:endParaRPr lang="en-US" sz="2400">
               <a:solidFill>
                 <a:srgbClr val="002060"/>
               </a:solidFill>
@@ -10656,7 +10656,7 @@
               <a:buNone/>
             </a:pPr>
             <a:r>
-              <a:rPr lang="en-US" b="1">
+              <a:rPr lang="en-US" sz="2400" b="1">
                 <a:solidFill>
                   <a:srgbClr val="002060"/>
                 </a:solidFill>
@@ -10665,7 +10665,7 @@
               <a:t>OP -&gt; </a:t>
             </a:r>
             <a:r>
-              <a:rPr lang="en-US">
+              <a:rPr lang="en-US" sz="2400">
                 <a:solidFill>
                   <a:srgbClr val="002060"/>
                 </a:solidFill>
@@ -10673,7 +10673,7 @@
               </a:rPr>
               <a:t>Invalid</a:t>
             </a:r>
-            <a:endParaRPr lang="en-US">
+            <a:endParaRPr lang="en-US" sz="2400">
               <a:solidFill>
                 <a:srgbClr val="002060"/>
               </a:solidFill>
@@ -12127,7 +12127,7 @@
               </a:lnSpc>
             </a:pPr>
             <a:r>
-              <a:rPr lang="en-US" sz="3400">
+              <a:rPr lang="en-US">
                 <a:solidFill>
                   <a:srgbClr val="002060"/>
                 </a:solidFill>
@@ -12135,7 +12135,7 @@
               </a:rPr>
               <a:t>Given array of elements : [2, -4, 6, -1, 3, -2]</a:t>
             </a:r>
-            <a:endParaRPr lang="en-US" sz="3400">
+            <a:endParaRPr lang="en-US">
               <a:solidFill>
                 <a:srgbClr val="002060"/>
               </a:solidFill>
@@ -12149,7 +12149,7 @@
               </a:lnSpc>
             </a:pPr>
             <a:r>
-              <a:rPr lang="en-US" sz="3400" b="1">
+              <a:rPr lang="en-US" b="1">
                 <a:solidFill>
                   <a:srgbClr val="002060"/>
                 </a:solidFill>
@@ -12158,7 +12158,7 @@
               <a:t>Step 2: </a:t>
             </a:r>
             <a:r>
-              <a:rPr lang="en-US" sz="3400">
+              <a:rPr lang="en-US">
                 <a:solidFill>
                   <a:srgbClr val="002060"/>
                 </a:solidFill>
@@ -12166,7 +12166,7 @@
               </a:rPr>
               <a:t>Next element (-4):  </a:t>
             </a:r>
-            <a:endParaRPr lang="en-US" sz="3400">
+            <a:endParaRPr lang="en-US">
               <a:solidFill>
                 <a:srgbClr val="002060"/>
               </a:solidFill>
@@ -12180,7 +12180,7 @@
               </a:lnSpc>
             </a:pPr>
             <a:r>
-              <a:rPr lang="en-US" sz="3200">
+              <a:rPr lang="en-US">
                 <a:solidFill>
                   <a:srgbClr val="002060"/>
                 </a:solidFill>
@@ -12188,7 +12188,7 @@
               </a:rPr>
               <a:t>current_start_index=1</a:t>
             </a:r>
-            <a:endParaRPr lang="en-US" sz="3200">
+            <a:endParaRPr lang="en-US">
               <a:solidFill>
                 <a:srgbClr val="002060"/>
               </a:solidFill>
@@ -12202,7 +12202,7 @@
               </a:lnSpc>
             </a:pPr>
             <a:r>
-              <a:rPr lang="en-US" sz="3200">
+              <a:rPr lang="en-US">
                 <a:solidFill>
                   <a:srgbClr val="002060"/>
                 </a:solidFill>
@@ -12210,7 +12210,7 @@
               </a:rPr>
               <a:t>current_end_index=2</a:t>
             </a:r>
-            <a:endParaRPr lang="en-US" sz="3200">
+            <a:endParaRPr lang="en-US">
               <a:solidFill>
                 <a:srgbClr val="002060"/>
               </a:solidFill>
@@ -12224,7 +12224,7 @@
               </a:lnSpc>
             </a:pPr>
             <a:r>
-              <a:rPr lang="en-US" sz="3200">
+              <a:rPr lang="en-US">
                 <a:solidFill>
                   <a:srgbClr val="002060"/>
                 </a:solidFill>
@@ -12232,7 +12232,7 @@
               </a:rPr>
               <a:t>current_sum = 2+(-4)</a:t>
             </a:r>
-            <a:endParaRPr lang="en-US" sz="3200">
+            <a:endParaRPr lang="en-US">
               <a:solidFill>
                 <a:srgbClr val="002060"/>
               </a:solidFill>
@@ -12246,7 +12246,7 @@
               </a:lnSpc>
             </a:pPr>
             <a:r>
-              <a:rPr lang="en-US" sz="3200">
+              <a:rPr lang="en-US">
                 <a:solidFill>
                   <a:srgbClr val="002060"/>
                 </a:solidFill>
@@ -12254,7 +12254,7 @@
               </a:rPr>
               <a:t>best_sum = 2</a:t>
             </a:r>
-            <a:endParaRPr lang="en-US" sz="3200">
+            <a:endParaRPr lang="en-US">
               <a:solidFill>
                 <a:srgbClr val="002060"/>
               </a:solidFill>
@@ -12268,7 +12268,7 @@
               </a:lnSpc>
             </a:pPr>
             <a:r>
-              <a:rPr lang="en-US" sz="3200">
+              <a:rPr lang="en-US">
                 <a:solidFill>
                   <a:srgbClr val="002060"/>
                 </a:solidFill>
@@ -12276,7 +12276,7 @@
               </a:rPr>
               <a:t>best_start_index = 1</a:t>
             </a:r>
-            <a:endParaRPr lang="en-US" sz="3200">
+            <a:endParaRPr lang="en-US">
               <a:solidFill>
                 <a:srgbClr val="002060"/>
               </a:solidFill>
@@ -12290,7 +12290,7 @@
               </a:lnSpc>
             </a:pPr>
             <a:r>
-              <a:rPr lang="en-US" sz="3200">
+              <a:rPr lang="en-US">
                 <a:solidFill>
                   <a:srgbClr val="002060"/>
                 </a:solidFill>
@@ -12298,7 +12298,7 @@
               </a:rPr>
               <a:t>best_end_index = 1</a:t>
             </a:r>
-            <a:endParaRPr lang="en-US" sz="3200">
+            <a:endParaRPr lang="en-US">
               <a:solidFill>
                 <a:srgbClr val="002060"/>
               </a:solidFill>
@@ -13135,7 +13135,7 @@
               </a:lnSpc>
             </a:pPr>
             <a:r>
-              <a:rPr lang="en-US" sz="3400">
+              <a:rPr lang="en-US">
                 <a:solidFill>
                   <a:srgbClr val="002060"/>
                 </a:solidFill>
@@ -13143,7 +13143,7 @@
               </a:rPr>
               <a:t>Given array of elements : [2, -4, 6, -1, 3, -2]</a:t>
             </a:r>
-            <a:endParaRPr lang="en-US" sz="3400">
+            <a:endParaRPr lang="en-US">
               <a:solidFill>
                 <a:srgbClr val="002060"/>
               </a:solidFill>
@@ -13157,7 +13157,7 @@
               </a:lnSpc>
             </a:pPr>
             <a:r>
-              <a:rPr lang="en-US" sz="3400" b="1">
+              <a:rPr lang="en-US" b="1">
                 <a:solidFill>
                   <a:srgbClr val="002060"/>
                 </a:solidFill>
@@ -13166,7 +13166,7 @@
               <a:t>Step 3: </a:t>
             </a:r>
             <a:r>
-              <a:rPr lang="en-US" sz="3400">
+              <a:rPr lang="en-US">
                 <a:solidFill>
                   <a:srgbClr val="002060"/>
                 </a:solidFill>
@@ -13174,7 +13174,7 @@
               </a:rPr>
               <a:t>Next element (6):  </a:t>
             </a:r>
-            <a:endParaRPr lang="en-US" sz="3400">
+            <a:endParaRPr lang="en-US">
               <a:solidFill>
                 <a:srgbClr val="002060"/>
               </a:solidFill>
@@ -13188,7 +13188,7 @@
               </a:lnSpc>
             </a:pPr>
             <a:r>
-              <a:rPr lang="en-US" sz="3200">
+              <a:rPr lang="en-US">
                 <a:solidFill>
                   <a:srgbClr val="002060"/>
                 </a:solidFill>
@@ -13196,7 +13196,7 @@
               </a:rPr>
               <a:t>current_start_index=3</a:t>
             </a:r>
-            <a:endParaRPr lang="en-US" sz="3200">
+            <a:endParaRPr lang="en-US">
               <a:solidFill>
                 <a:srgbClr val="002060"/>
               </a:solidFill>
@@ -13210,7 +13210,7 @@
               </a:lnSpc>
             </a:pPr>
             <a:r>
-              <a:rPr lang="en-US" sz="3200">
+              <a:rPr lang="en-US">
                 <a:solidFill>
                   <a:srgbClr val="002060"/>
                 </a:solidFill>
@@ -13218,7 +13218,7 @@
               </a:rPr>
               <a:t>current_end_index=3</a:t>
             </a:r>
-            <a:endParaRPr lang="en-US" sz="3200">
+            <a:endParaRPr lang="en-US">
               <a:solidFill>
                 <a:srgbClr val="002060"/>
               </a:solidFill>
@@ -13232,7 +13232,7 @@
               </a:lnSpc>
             </a:pPr>
             <a:r>
-              <a:rPr lang="en-US" sz="3200">
+              <a:rPr lang="en-US">
                 <a:solidFill>
                   <a:srgbClr val="002060"/>
                 </a:solidFill>
@@ -13240,7 +13240,7 @@
               </a:rPr>
               <a:t>current_sum = 6</a:t>
             </a:r>
-            <a:endParaRPr lang="en-US" sz="3200">
+            <a:endParaRPr lang="en-US">
               <a:solidFill>
                 <a:srgbClr val="002060"/>
               </a:solidFill>
@@ -13254,7 +13254,7 @@
               </a:lnSpc>
             </a:pPr>
             <a:r>
-              <a:rPr lang="en-US" sz="3200">
+              <a:rPr lang="en-US">
                 <a:solidFill>
                   <a:srgbClr val="002060"/>
                 </a:solidFill>
@@ -13262,7 +13262,7 @@
               </a:rPr>
               <a:t>best_sum = 6</a:t>
             </a:r>
-            <a:endParaRPr lang="en-US" sz="3200">
+            <a:endParaRPr lang="en-US">
               <a:solidFill>
                 <a:srgbClr val="002060"/>
               </a:solidFill>
@@ -13276,7 +13276,7 @@
               </a:lnSpc>
             </a:pPr>
             <a:r>
-              <a:rPr lang="en-US" sz="3200">
+              <a:rPr lang="en-US">
                 <a:solidFill>
                   <a:srgbClr val="002060"/>
                 </a:solidFill>
@@ -13284,7 +13284,7 @@
               </a:rPr>
               <a:t>best_start_index = 3</a:t>
             </a:r>
-            <a:endParaRPr lang="en-US" sz="3200">
+            <a:endParaRPr lang="en-US">
               <a:solidFill>
                 <a:srgbClr val="002060"/>
               </a:solidFill>
@@ -13298,7 +13298,7 @@
               </a:lnSpc>
             </a:pPr>
             <a:r>
-              <a:rPr lang="en-US" sz="3200">
+              <a:rPr lang="en-US">
                 <a:solidFill>
                   <a:srgbClr val="002060"/>
                 </a:solidFill>
@@ -13306,7 +13306,7 @@
               </a:rPr>
               <a:t>best_end_index = 3</a:t>
             </a:r>
-            <a:endParaRPr lang="en-US" sz="3200">
+            <a:endParaRPr lang="en-US">
               <a:solidFill>
                 <a:srgbClr val="002060"/>
               </a:solidFill>
@@ -14143,7 +14143,7 @@
               </a:lnSpc>
             </a:pPr>
             <a:r>
-              <a:rPr lang="en-US" sz="3400">
+              <a:rPr lang="en-US">
                 <a:solidFill>
                   <a:srgbClr val="002060"/>
                 </a:solidFill>
@@ -14151,7 +14151,7 @@
               </a:rPr>
               <a:t>Given array of elements : [2, -4, 6, -1, 3, -2]</a:t>
             </a:r>
-            <a:endParaRPr lang="en-US" sz="3400">
+            <a:endParaRPr lang="en-US">
               <a:solidFill>
                 <a:srgbClr val="002060"/>
               </a:solidFill>
@@ -14165,7 +14165,7 @@
               </a:lnSpc>
             </a:pPr>
             <a:r>
-              <a:rPr lang="en-US" sz="3400" b="1">
+              <a:rPr lang="en-US" b="1">
                 <a:solidFill>
                   <a:srgbClr val="002060"/>
                 </a:solidFill>
@@ -14174,7 +14174,7 @@
               <a:t>Step 4: </a:t>
             </a:r>
             <a:r>
-              <a:rPr lang="en-US" sz="3400">
+              <a:rPr lang="en-US">
                 <a:solidFill>
                   <a:srgbClr val="002060"/>
                 </a:solidFill>
@@ -14182,7 +14182,7 @@
               </a:rPr>
               <a:t>Next element (-1):  </a:t>
             </a:r>
-            <a:endParaRPr lang="en-US" sz="3400">
+            <a:endParaRPr lang="en-US">
               <a:solidFill>
                 <a:srgbClr val="002060"/>
               </a:solidFill>
@@ -14196,7 +14196,7 @@
               </a:lnSpc>
             </a:pPr>
             <a:r>
-              <a:rPr lang="en-US" sz="3200">
+              <a:rPr lang="en-US">
                 <a:solidFill>
                   <a:srgbClr val="002060"/>
                 </a:solidFill>
@@ -14204,7 +14204,7 @@
               </a:rPr>
               <a:t>current_start_index=3</a:t>
             </a:r>
-            <a:endParaRPr lang="en-US" sz="3200">
+            <a:endParaRPr lang="en-US">
               <a:solidFill>
                 <a:srgbClr val="002060"/>
               </a:solidFill>
@@ -14218,7 +14218,7 @@
               </a:lnSpc>
             </a:pPr>
             <a:r>
-              <a:rPr lang="en-US" sz="3200">
+              <a:rPr lang="en-US">
                 <a:solidFill>
                   <a:srgbClr val="002060"/>
                 </a:solidFill>
@@ -14226,7 +14226,7 @@
               </a:rPr>
               <a:t>current_end_index=4</a:t>
             </a:r>
-            <a:endParaRPr lang="en-US" sz="3200">
+            <a:endParaRPr lang="en-US">
               <a:solidFill>
                 <a:srgbClr val="002060"/>
               </a:solidFill>
@@ -14240,7 +14240,7 @@
               </a:lnSpc>
             </a:pPr>
             <a:r>
-              <a:rPr lang="en-US" sz="3200">
+              <a:rPr lang="en-US">
                 <a:solidFill>
                   <a:srgbClr val="002060"/>
                 </a:solidFill>
@@ -14248,7 +14248,7 @@
               </a:rPr>
               <a:t>current_sum = 5</a:t>
             </a:r>
-            <a:endParaRPr lang="en-US" sz="3200">
+            <a:endParaRPr lang="en-US">
               <a:solidFill>
                 <a:srgbClr val="002060"/>
               </a:solidFill>
@@ -14262,7 +14262,7 @@
               </a:lnSpc>
             </a:pPr>
             <a:r>
-              <a:rPr lang="en-US" sz="3200">
+              <a:rPr lang="en-US">
                 <a:solidFill>
                   <a:srgbClr val="002060"/>
                 </a:solidFill>
@@ -14270,7 +14270,7 @@
               </a:rPr>
               <a:t>best_sum = 6</a:t>
             </a:r>
-            <a:endParaRPr lang="en-US" sz="3200">
+            <a:endParaRPr lang="en-US">
               <a:solidFill>
                 <a:srgbClr val="002060"/>
               </a:solidFill>
@@ -14284,7 +14284,7 @@
               </a:lnSpc>
             </a:pPr>
             <a:r>
-              <a:rPr lang="en-US" sz="3200">
+              <a:rPr lang="en-US">
                 <a:solidFill>
                   <a:srgbClr val="002060"/>
                 </a:solidFill>
@@ -14292,7 +14292,7 @@
               </a:rPr>
               <a:t>best_start_index = 3</a:t>
             </a:r>
-            <a:endParaRPr lang="en-US" sz="3200">
+            <a:endParaRPr lang="en-US">
               <a:solidFill>
                 <a:srgbClr val="002060"/>
               </a:solidFill>
@@ -14306,7 +14306,7 @@
               </a:lnSpc>
             </a:pPr>
             <a:r>
-              <a:rPr lang="en-US" sz="3200">
+              <a:rPr lang="en-US">
                 <a:solidFill>
                   <a:srgbClr val="002060"/>
                 </a:solidFill>
@@ -14314,7 +14314,7 @@
               </a:rPr>
               <a:t>best_end_index = 3</a:t>
             </a:r>
-            <a:endParaRPr lang="en-US" sz="3200">
+            <a:endParaRPr lang="en-US">
               <a:solidFill>
                 <a:srgbClr val="002060"/>
               </a:solidFill>
@@ -15151,7 +15151,7 @@
               </a:lnSpc>
             </a:pPr>
             <a:r>
-              <a:rPr lang="en-US" sz="3400">
+              <a:rPr lang="en-US">
                 <a:solidFill>
                   <a:srgbClr val="002060"/>
                 </a:solidFill>
@@ -15159,7 +15159,7 @@
               </a:rPr>
               <a:t>Given array of elements : [2, -4, 6, -1, 3, -2]</a:t>
             </a:r>
-            <a:endParaRPr lang="en-US" sz="3400">
+            <a:endParaRPr lang="en-US">
               <a:solidFill>
                 <a:srgbClr val="002060"/>
               </a:solidFill>
@@ -15173,7 +15173,7 @@
               </a:lnSpc>
             </a:pPr>
             <a:r>
-              <a:rPr lang="en-US" sz="3400" b="1">
+              <a:rPr lang="en-US" b="1">
                 <a:solidFill>
                   <a:srgbClr val="002060"/>
                 </a:solidFill>
@@ -15182,7 +15182,7 @@
               <a:t>Step 5: </a:t>
             </a:r>
             <a:r>
-              <a:rPr lang="en-US" sz="3400">
+              <a:rPr lang="en-US">
                 <a:solidFill>
                   <a:srgbClr val="002060"/>
                 </a:solidFill>
@@ -15190,7 +15190,7 @@
               </a:rPr>
               <a:t>Next element (3):  </a:t>
             </a:r>
-            <a:endParaRPr lang="en-US" sz="3400">
+            <a:endParaRPr lang="en-US">
               <a:solidFill>
                 <a:srgbClr val="002060"/>
               </a:solidFill>
@@ -15204,7 +15204,7 @@
               </a:lnSpc>
             </a:pPr>
             <a:r>
-              <a:rPr lang="en-US" sz="3200">
+              <a:rPr lang="en-US">
                 <a:solidFill>
                   <a:srgbClr val="002060"/>
                 </a:solidFill>
@@ -15212,7 +15212,7 @@
               </a:rPr>
               <a:t>current_start_index=3</a:t>
             </a:r>
-            <a:endParaRPr lang="en-US" sz="3200">
+            <a:endParaRPr lang="en-US">
               <a:solidFill>
                 <a:srgbClr val="002060"/>
               </a:solidFill>
@@ -15226,7 +15226,7 @@
               </a:lnSpc>
             </a:pPr>
             <a:r>
-              <a:rPr lang="en-US" sz="3200">
+              <a:rPr lang="en-US">
                 <a:solidFill>
                   <a:srgbClr val="002060"/>
                 </a:solidFill>
@@ -15234,7 +15234,7 @@
               </a:rPr>
               <a:t>current_end_index=5</a:t>
             </a:r>
-            <a:endParaRPr lang="en-US" sz="3200">
+            <a:endParaRPr lang="en-US">
               <a:solidFill>
                 <a:srgbClr val="002060"/>
               </a:solidFill>
@@ -15248,7 +15248,7 @@
               </a:lnSpc>
             </a:pPr>
             <a:r>
-              <a:rPr lang="en-US" sz="3200">
+              <a:rPr lang="en-US">
                 <a:solidFill>
                   <a:srgbClr val="002060"/>
                 </a:solidFill>
@@ -15256,7 +15256,7 @@
               </a:rPr>
               <a:t>current_sum = 8</a:t>
             </a:r>
-            <a:endParaRPr lang="en-US" sz="3200">
+            <a:endParaRPr lang="en-US">
               <a:solidFill>
                 <a:srgbClr val="002060"/>
               </a:solidFill>
@@ -15270,7 +15270,7 @@
               </a:lnSpc>
             </a:pPr>
             <a:r>
-              <a:rPr lang="en-US" sz="3200">
+              <a:rPr lang="en-US">
                 <a:solidFill>
                   <a:srgbClr val="002060"/>
                 </a:solidFill>
@@ -15278,7 +15278,7 @@
               </a:rPr>
               <a:t>best_sum = 8</a:t>
             </a:r>
-            <a:endParaRPr lang="en-US" sz="3200">
+            <a:endParaRPr lang="en-US">
               <a:solidFill>
                 <a:srgbClr val="002060"/>
               </a:solidFill>
@@ -15292,7 +15292,7 @@
               </a:lnSpc>
             </a:pPr>
             <a:r>
-              <a:rPr lang="en-US" sz="3200">
+              <a:rPr lang="en-US">
                 <a:solidFill>
                   <a:srgbClr val="002060"/>
                 </a:solidFill>
@@ -15300,7 +15300,7 @@
               </a:rPr>
               <a:t>best_start_index = 3</a:t>
             </a:r>
-            <a:endParaRPr lang="en-US" sz="3200">
+            <a:endParaRPr lang="en-US">
               <a:solidFill>
                 <a:srgbClr val="002060"/>
               </a:solidFill>
@@ -15314,7 +15314,7 @@
               </a:lnSpc>
             </a:pPr>
             <a:r>
-              <a:rPr lang="en-US" sz="3200">
+              <a:rPr lang="en-US">
                 <a:solidFill>
                   <a:srgbClr val="002060"/>
                 </a:solidFill>
@@ -15322,7 +15322,7 @@
               </a:rPr>
               <a:t>best_end_index = 5</a:t>
             </a:r>
-            <a:endParaRPr lang="en-US" sz="3200">
+            <a:endParaRPr lang="en-US">
               <a:solidFill>
                 <a:srgbClr val="002060"/>
               </a:solidFill>
@@ -16159,7 +16159,7 @@
               </a:lnSpc>
             </a:pPr>
             <a:r>
-              <a:rPr lang="en-US" sz="3400">
+              <a:rPr lang="en-US">
                 <a:solidFill>
                   <a:srgbClr val="002060"/>
                 </a:solidFill>
@@ -16167,7 +16167,7 @@
               </a:rPr>
               <a:t>Given array of elements : [2, -4, 6, -1, 3, -2]</a:t>
             </a:r>
-            <a:endParaRPr lang="en-US" sz="3400">
+            <a:endParaRPr lang="en-US">
               <a:solidFill>
                 <a:srgbClr val="002060"/>
               </a:solidFill>
@@ -16181,7 +16181,7 @@
               </a:lnSpc>
             </a:pPr>
             <a:r>
-              <a:rPr lang="en-US" sz="3400" b="1">
+              <a:rPr lang="en-US" b="1">
                 <a:solidFill>
                   <a:srgbClr val="002060"/>
                 </a:solidFill>
@@ -16190,7 +16190,7 @@
               <a:t>Step 6: </a:t>
             </a:r>
             <a:r>
-              <a:rPr lang="en-US" sz="3400">
+              <a:rPr lang="en-US">
                 <a:solidFill>
                   <a:srgbClr val="002060"/>
                 </a:solidFill>
@@ -16198,7 +16198,7 @@
               </a:rPr>
               <a:t>Next element (-2):  </a:t>
             </a:r>
-            <a:endParaRPr lang="en-US" sz="3400">
+            <a:endParaRPr lang="en-US">
               <a:solidFill>
                 <a:srgbClr val="002060"/>
               </a:solidFill>
@@ -16212,7 +16212,7 @@
               </a:lnSpc>
             </a:pPr>
             <a:r>
-              <a:rPr lang="en-US" sz="3200">
+              <a:rPr lang="en-US">
                 <a:solidFill>
                   <a:srgbClr val="002060"/>
                 </a:solidFill>
@@ -16220,7 +16220,7 @@
               </a:rPr>
               <a:t>current_start_index=3</a:t>
             </a:r>
-            <a:endParaRPr lang="en-US" sz="3200">
+            <a:endParaRPr lang="en-US">
               <a:solidFill>
                 <a:srgbClr val="002060"/>
               </a:solidFill>
@@ -16234,7 +16234,7 @@
               </a:lnSpc>
             </a:pPr>
             <a:r>
-              <a:rPr lang="en-US" sz="3200">
+              <a:rPr lang="en-US">
                 <a:solidFill>
                   <a:srgbClr val="002060"/>
                 </a:solidFill>
@@ -16242,7 +16242,7 @@
               </a:rPr>
               <a:t>current_end_index=6</a:t>
             </a:r>
-            <a:endParaRPr lang="en-US" sz="3200">
+            <a:endParaRPr lang="en-US">
               <a:solidFill>
                 <a:srgbClr val="002060"/>
               </a:solidFill>
@@ -16256,7 +16256,7 @@
               </a:lnSpc>
             </a:pPr>
             <a:r>
-              <a:rPr lang="en-US" sz="3200">
+              <a:rPr lang="en-US">
                 <a:solidFill>
                   <a:srgbClr val="002060"/>
                 </a:solidFill>
@@ -16264,7 +16264,7 @@
               </a:rPr>
               <a:t>current_sum = 6</a:t>
             </a:r>
-            <a:endParaRPr lang="en-US" sz="3200">
+            <a:endParaRPr lang="en-US">
               <a:solidFill>
                 <a:srgbClr val="002060"/>
               </a:solidFill>
@@ -16278,7 +16278,7 @@
               </a:lnSpc>
             </a:pPr>
             <a:r>
-              <a:rPr lang="en-US" sz="3200">
+              <a:rPr lang="en-US">
                 <a:solidFill>
                   <a:srgbClr val="002060"/>
                 </a:solidFill>
@@ -16286,7 +16286,7 @@
               </a:rPr>
               <a:t>best_sum = 8</a:t>
             </a:r>
-            <a:endParaRPr lang="en-US" sz="3200">
+            <a:endParaRPr lang="en-US">
               <a:solidFill>
                 <a:srgbClr val="002060"/>
               </a:solidFill>
@@ -16300,7 +16300,7 @@
               </a:lnSpc>
             </a:pPr>
             <a:r>
-              <a:rPr lang="en-US" sz="3200">
+              <a:rPr lang="en-US">
                 <a:solidFill>
                   <a:srgbClr val="002060"/>
                 </a:solidFill>
@@ -16308,7 +16308,7 @@
               </a:rPr>
               <a:t>best_start_index = 3</a:t>
             </a:r>
-            <a:endParaRPr lang="en-US" sz="3200">
+            <a:endParaRPr lang="en-US">
               <a:solidFill>
                 <a:srgbClr val="002060"/>
               </a:solidFill>
@@ -16322,7 +16322,7 @@
               </a:lnSpc>
             </a:pPr>
             <a:r>
-              <a:rPr lang="en-US" sz="3200">
+              <a:rPr lang="en-US">
                 <a:solidFill>
                   <a:srgbClr val="002060"/>
                 </a:solidFill>
@@ -16330,7 +16330,7 @@
               </a:rPr>
               <a:t>best_end_index = 5</a:t>
             </a:r>
-            <a:endParaRPr lang="en-US" sz="3200">
+            <a:endParaRPr lang="en-US">
               <a:solidFill>
                 <a:srgbClr val="002060"/>
               </a:solidFill>

</xml_diff>